<commit_message>
Fix deck overflow: titles no longer wrap into body, content fits the page
Section titles were centred in narrow template boxes, wrapping to two
lines and colliding with the body text below; body text also ran off
the bottom edge. Widens and left-aligns the titles, lifts the content
block into the 1.5in of unused space above, tightens line spacing and
shortens the longest answers. Verified by rendering all six slides.

Co-Authored-By: Claude Opus 5 <noreply@anthropic.com>
Claude-Session: https://claude.ai/code/session_01NrpayY9WZKBwBF3PAuRKD6
</commit_message>
<xml_diff>
--- a/docs/deck/ECO-ARB_VNAK-753_VinHack2026.pptx
+++ b/docs/deck/ECO-ARB_VNAK-753_VinHack2026.pptx
@@ -3394,8 +3394,8 @@
         </p:nvSpPr>
         <p:spPr>
           <a:xfrm rot="0">
-            <a:off x="3377654" y="4596466"/>
-            <a:ext cx="8503920" cy="3840480"/>
+            <a:off x="3377654" y="3346704"/>
+            <a:ext cx="8138160" cy="5541264"/>
           </a:xfrm>
           <a:prstGeom prst="rect">
             <a:avLst/>
@@ -3409,8 +3409,14 @@
           <a:p>
             <a:pPr algn="l" marL="539749" indent="-269875" lvl="1">
               <a:lnSpc>
-                <a:spcPts val="3499"/>
+                <a:spcPct val="100000"/>
               </a:lnSpc>
+              <a:spcBef>
+                <a:spcPts val="0"/>
+              </a:spcBef>
+              <a:spcAft>
+                <a:spcPts val="900"/>
+              </a:spcAft>
               <a:buFont typeface="Arial"/>
               <a:buChar char="•"/>
             </a:pPr>
@@ -3442,8 +3448,14 @@
           <a:p>
             <a:pPr algn="l" marL="539749" indent="-269875" lvl="1">
               <a:lnSpc>
-                <a:spcPts val="3499"/>
+                <a:spcPct val="100000"/>
               </a:lnSpc>
+              <a:spcBef>
+                <a:spcPts val="0"/>
+              </a:spcBef>
+              <a:spcAft>
+                <a:spcPts val="900"/>
+              </a:spcAft>
               <a:buFont typeface="Arial"/>
               <a:buChar char="•"/>
             </a:pPr>
@@ -3475,8 +3487,14 @@
           <a:p>
             <a:pPr algn="l" marL="539749" indent="-269875" lvl="1">
               <a:lnSpc>
-                <a:spcPts val="3499"/>
+                <a:spcPct val="100000"/>
               </a:lnSpc>
+              <a:spcBef>
+                <a:spcPts val="0"/>
+              </a:spcBef>
+              <a:spcAft>
+                <a:spcPts val="900"/>
+              </a:spcAft>
               <a:buFont typeface="Arial"/>
               <a:buChar char="•"/>
             </a:pPr>
@@ -3508,8 +3526,14 @@
           <a:p>
             <a:pPr algn="l" marL="539749" indent="-269875" lvl="1">
               <a:lnSpc>
-                <a:spcPts val="3499"/>
+                <a:spcPct val="100000"/>
               </a:lnSpc>
+              <a:spcBef>
+                <a:spcPts val="0"/>
+              </a:spcBef>
+              <a:spcAft>
+                <a:spcPts val="900"/>
+              </a:spcAft>
               <a:buFont typeface="Arial"/>
               <a:buChar char="•"/>
             </a:pPr>
@@ -3541,13 +3565,19 @@
           <a:p>
             <a:pPr algn="l" marL="539749" indent="-269875" lvl="1">
               <a:lnSpc>
-                <a:spcPts val="3499"/>
+                <a:spcPct val="100000"/>
               </a:lnSpc>
+              <a:spcBef>
+                <a:spcPts val="0"/>
+              </a:spcBef>
+              <a:spcAft>
+                <a:spcPts val="900"/>
+              </a:spcAft>
               <a:buFont typeface="Arial"/>
               <a:buChar char="•"/>
             </a:pPr>
             <a:r>
-              <a:rPr lang="en-US" sz="2100">
+              <a:rPr lang="en-US" sz="2100" b="0">
                 <a:solidFill>
                   <a:srgbClr val="000000"/>
                 </a:solidFill>
@@ -3556,14 +3586,20 @@
                 <a:cs typeface="Aristotelica Pro"/>
                 <a:sym typeface="Aristotelica Pro"/>
               </a:rPr>
-              <a:t>A carbon-aware scheduler that moves deferrable compute to the cleanest half-hour the electricity grid will offer before your deadline — and proves the work actually ran.</a:t>
+              <a:t>A carbon-aware scheduler that moves deferrable compute to the cleanest half-hour the grid will offer before your deadline — and proves the work actually ran.</a:t>
             </a:r>
           </a:p>
           <a:p>
             <a:pPr algn="l" marL="539749" indent="-269875" lvl="1">
               <a:lnSpc>
-                <a:spcPts val="3499"/>
+                <a:spcPct val="100000"/>
               </a:lnSpc>
+              <a:spcBef>
+                <a:spcPts val="0"/>
+              </a:spcBef>
+              <a:spcAft>
+                <a:spcPts val="900"/>
+              </a:spcAft>
               <a:buFont typeface="Arial"/>
               <a:buChar char="•"/>
             </a:pPr>
@@ -3609,26 +3645,26 @@
         </p:nvSpPr>
         <p:spPr>
           <a:xfrm rot="0">
-            <a:off x="3377654" y="3605866"/>
-            <a:ext cx="4325371" cy="1038225"/>
+            <a:off x="3377654" y="2240280"/>
+            <a:ext cx="8229600" cy="960120"/>
           </a:xfrm>
           <a:prstGeom prst="rect">
             <a:avLst/>
           </a:prstGeom>
         </p:spPr>
         <p:txBody>
-          <a:bodyPr anchor="t" rtlCol="false" tIns="0" lIns="0" bIns="0" rIns="0">
+          <a:bodyPr anchor="t" rtlCol="false" tIns="0" lIns="0" bIns="0" rIns="0" wrap="square">
             <a:spAutoFit/>
           </a:bodyPr>
           <a:lstStyle/>
           <a:p>
-            <a:pPr algn="ctr">
+            <a:pPr algn="l">
               <a:lnSpc>
                 <a:spcPts val="8400"/>
               </a:lnSpc>
             </a:pPr>
             <a:r>
-              <a:rPr lang="en-US" b="true" sz="6000">
+              <a:rPr lang="en-US" b="true" sz="6600">
                 <a:solidFill>
                   <a:srgbClr val="000000"/>
                 </a:solidFill>
@@ -3796,8 +3832,8 @@
         </p:blipFill>
         <p:spPr>
           <a:xfrm>
-            <a:off x="11932920" y="3913632"/>
-            <a:ext cx="5532120" cy="4041648"/>
+            <a:off x="11155680" y="3346704"/>
+            <a:ext cx="6309360" cy="4608576"/>
           </a:xfrm>
           <a:prstGeom prst="rect">
             <a:avLst/>
@@ -4149,8 +4185,8 @@
         </p:nvSpPr>
         <p:spPr>
           <a:xfrm rot="0">
-            <a:off x="3536285" y="4551059"/>
-            <a:ext cx="13560552" cy="4480560"/>
+            <a:off x="3536285" y="3346704"/>
+            <a:ext cx="13560552" cy="5541264"/>
           </a:xfrm>
           <a:prstGeom prst="rect">
             <a:avLst/>
@@ -4164,8 +4200,14 @@
           <a:p>
             <a:pPr algn="l" marL="539749" indent="-269875" lvl="1">
               <a:lnSpc>
-                <a:spcPts val="3499"/>
+                <a:spcPct val="100000"/>
               </a:lnSpc>
+              <a:spcBef>
+                <a:spcPts val="0"/>
+              </a:spcBef>
+              <a:spcAft>
+                <a:spcPts val="900"/>
+              </a:spcAft>
               <a:buFont typeface="Arial"/>
               <a:buChar char="•"/>
             </a:pPr>
@@ -4191,14 +4233,20 @@
                 <a:cs typeface="Aristotelica Pro"/>
                 <a:sym typeface="Aristotelica Pro"/>
               </a:rPr>
-              <a:t>Deferrable compute runs the instant it is submitted, on whatever electricity happens to be in the wires. UK grid carbon intensity swings between roughly 60 and 350 gCO₂/kWh within a single day, so identical work emits four to five times more or less for one reason only — when it started.</a:t>
+              <a:t>Deferrable compute runs the instant it is submitted, on whatever electricity is in the wires. UK grid carbon intensity swings between roughly 60 and 350 gCO₂/kWh in a single day — so identical work emits four to five times more or less, for one reason only: when it started.</a:t>
             </a:r>
           </a:p>
           <a:p>
             <a:pPr algn="l" marL="539749" indent="-269875" lvl="1">
               <a:lnSpc>
-                <a:spcPts val="3499"/>
+                <a:spcPct val="100000"/>
               </a:lnSpc>
+              <a:spcBef>
+                <a:spcPts val="0"/>
+              </a:spcBef>
+              <a:spcAft>
+                <a:spcPts val="900"/>
+              </a:spcAft>
               <a:buFont typeface="Arial"/>
               <a:buChar char="•"/>
             </a:pPr>
@@ -4224,14 +4272,20 @@
                 <a:cs typeface="Aristotelica Pro"/>
                 <a:sym typeface="Aristotelica Pro"/>
               </a:rPr>
-              <a:t>Platform, DevOps and research-computing teams running nightly builds, CI pipelines, model training, backups and simulation sweeps; cloud operators under emissions-reporting obligations; and the grid itself, where demand that ignores supply forces dirtier plant online at peak.</a:t>
+              <a:t>Platform, DevOps and research-computing teams running nightly builds, CI pipelines, model training, backups and simulation sweeps — plus cloud operators under emissions-reporting obligations.</a:t>
             </a:r>
           </a:p>
           <a:p>
             <a:pPr algn="l" marL="539749" indent="-269875" lvl="1">
               <a:lnSpc>
-                <a:spcPts val="3499"/>
+                <a:spcPct val="100000"/>
               </a:lnSpc>
+              <a:spcBef>
+                <a:spcPts val="0"/>
+              </a:spcBef>
+              <a:spcAft>
+                <a:spcPts val="900"/>
+              </a:spcAft>
               <a:buFont typeface="Arial"/>
               <a:buChar char="•"/>
             </a:pPr>
@@ -4263,8 +4317,14 @@
           <a:p>
             <a:pPr algn="l" marL="539749" indent="-269875" lvl="1">
               <a:lnSpc>
-                <a:spcPts val="3499"/>
+                <a:spcPct val="100000"/>
               </a:lnSpc>
+              <a:spcBef>
+                <a:spcPts val="0"/>
+              </a:spcBef>
+              <a:spcAft>
+                <a:spcPts val="900"/>
+              </a:spcAft>
               <a:buFont typeface="Arial"/>
               <a:buChar char="•"/>
             </a:pPr>
@@ -4290,14 +4350,20 @@
                 <a:cs typeface="Aristotelica Pro"/>
                 <a:sym typeface="Aristotelica Pro"/>
               </a:rPr>
-              <a:t>Schedulers optimise latency, queue depth and cost; none optimise carbon. Carbon dashboards report emissions after the fact instead of acting on them. The carbon-aware tools that do exist shift jobs between regions, which needs multi-region infrastructure most teams simply do not have.</a:t>
+              <a:t>Schedulers optimise latency, queue depth and cost; none optimise carbon. Dashboards report emissions after the fact instead of acting. The carbon-aware tools that exist shift jobs between regions, needing infrastructure most teams do not have.</a:t>
             </a:r>
           </a:p>
           <a:p>
             <a:pPr algn="l" marL="539749" indent="-269875" lvl="1">
               <a:lnSpc>
-                <a:spcPts val="3499"/>
+                <a:spcPct val="100000"/>
               </a:lnSpc>
+              <a:spcBef>
+                <a:spcPts val="0"/>
+              </a:spcBef>
+              <a:spcAft>
+                <a:spcPts val="900"/>
+              </a:spcAft>
               <a:buFont typeface="Arial"/>
               <a:buChar char="•"/>
             </a:pPr>
@@ -4323,7 +4389,7 @@
                 <a:cs typeface="Aristotelica Pro"/>
                 <a:sym typeface="Aristotelica Pro"/>
               </a:rPr>
-              <a:t>Climate Tech and Resilience — it cuts real emissions with no new hardware and no change to the job itself, while pulling flexible demand toward renewable surplus, which is exactly what a resilient grid needs.</a:t>
+              <a:t>Climate Tech and Resilience — it cuts real emissions with no new hardware and no change to the job, while pulling flexible demand toward renewable surplus, which is what a resilient grid needs.</a:t>
             </a:r>
           </a:p>
           <a:p>
@@ -4350,26 +4416,26 @@
         </p:nvSpPr>
         <p:spPr>
           <a:xfrm rot="0">
-            <a:off x="3536285" y="3560459"/>
-            <a:ext cx="5139931" cy="1038225"/>
+            <a:off x="3536285" y="2240280"/>
+            <a:ext cx="10972800" cy="960120"/>
           </a:xfrm>
           <a:prstGeom prst="rect">
             <a:avLst/>
           </a:prstGeom>
         </p:spPr>
         <p:txBody>
-          <a:bodyPr anchor="t" rtlCol="false" tIns="0" lIns="0" bIns="0" rIns="0">
+          <a:bodyPr anchor="t" rtlCol="false" tIns="0" lIns="0" bIns="0" rIns="0" wrap="square">
             <a:spAutoFit/>
           </a:bodyPr>
           <a:lstStyle/>
           <a:p>
-            <a:pPr algn="ctr">
+            <a:pPr algn="l">
               <a:lnSpc>
                 <a:spcPts val="8400"/>
               </a:lnSpc>
             </a:pPr>
             <a:r>
-              <a:rPr lang="en-US" b="true" sz="6000">
+              <a:rPr lang="en-US" b="true" sz="5400">
                 <a:solidFill>
                   <a:srgbClr val="000000"/>
                 </a:solidFill>
@@ -4866,8 +4932,8 @@
         </p:nvSpPr>
         <p:spPr>
           <a:xfrm rot="0">
-            <a:off x="3456097" y="4628442"/>
-            <a:ext cx="13560552" cy="4206240"/>
+            <a:off x="3456097" y="3346704"/>
+            <a:ext cx="13560552" cy="5541264"/>
           </a:xfrm>
           <a:prstGeom prst="rect">
             <a:avLst/>
@@ -4881,8 +4947,14 @@
           <a:p>
             <a:pPr algn="l" marL="539749" indent="-269875" lvl="1">
               <a:lnSpc>
-                <a:spcPts val="3499"/>
+                <a:spcPct val="100000"/>
               </a:lnSpc>
+              <a:spcBef>
+                <a:spcPts val="0"/>
+              </a:spcBef>
+              <a:spcAft>
+                <a:spcPts val="900"/>
+              </a:spcAft>
               <a:buFont typeface="Arial"/>
               <a:buChar char="•"/>
             </a:pPr>
@@ -4908,14 +4980,20 @@
                 <a:cs typeface="Aristotelica Pro"/>
                 <a:sym typeface="Aristotelica Pro"/>
               </a:rPr>
-              <a:t>A carbon-aware compute scheduler. You give it a job, an energy budget and a deadline; it decides when that job should run, holds it until then, and executes it for real.</a:t>
+              <a:t>A carbon-aware compute scheduler. You give it a job, an energy budget and a deadline; it decides when that job runs, holds it until then, and executes it for real.</a:t>
             </a:r>
           </a:p>
           <a:p>
             <a:pPr algn="l" marL="539749" indent="-269875" lvl="1">
               <a:lnSpc>
-                <a:spcPts val="3499"/>
+                <a:spcPct val="100000"/>
               </a:lnSpc>
+              <a:spcBef>
+                <a:spcPts val="0"/>
+              </a:spcBef>
+              <a:spcAft>
+                <a:spcPts val="900"/>
+              </a:spcAft>
               <a:buFont typeface="Arial"/>
               <a:buChar char="•"/>
             </a:pPr>
@@ -4929,7 +5007,7 @@
                 <a:cs typeface="Aristotelica Pro"/>
                 <a:sym typeface="Aristotelica Pro"/>
               </a:rPr>
-              <a:t>The fundamental approach.  </a:t>
+              <a:t>The approach.  </a:t>
             </a:r>
             <a:r>
               <a:rPr lang="en-US" sz="1700" b="0">
@@ -4941,14 +5019,20 @@
                 <a:cs typeface="Aristotelica Pro"/>
                 <a:sym typeface="Aristotelica Pro"/>
               </a:rPr>
-              <a:t>Treat the deadline as the only hard constraint and the start time as free. Carbon over a fixed-width window is piecewise-linear in start time, so the minimum always falls on a breakpoint — a start where either end of the window crosses a forecast slot edge. That set is finite, so we enumerate it exhaustively instead of sampling.</a:t>
+              <a:t>Treat the deadline as the only hard constraint and the start time as free. Carbon over a fixed-width window is piecewise-linear in start time, so the minimum always falls on a breakpoint — where either end of the window crosses a forecast slot edge. That set is finite, so we enumerate it exhaustively instead of sampling.</a:t>
             </a:r>
           </a:p>
           <a:p>
             <a:pPr algn="l" marL="539749" indent="-269875" lvl="1">
               <a:lnSpc>
-                <a:spcPts val="3499"/>
+                <a:spcPct val="100000"/>
               </a:lnSpc>
+              <a:spcBef>
+                <a:spcPts val="0"/>
+              </a:spcBef>
+              <a:spcAft>
+                <a:spcPts val="900"/>
+              </a:spcAft>
               <a:buFont typeface="Arial"/>
               <a:buChar char="•"/>
             </a:pPr>
@@ -4974,14 +5058,20 @@
                 <a:cs typeface="Aristotelica Pro"/>
                 <a:sym typeface="Aristotelica Pro"/>
               </a:rPr>
-              <a:t>Live National Grid forecast ingest with provenance on every slot; provably optimal window search; real workload execution with a chained SHA-256 receipt; continuous re-planning as the forecast moves; a non-mutating preview; and clearly labelled time compression for demos.</a:t>
+              <a:t>Live National Grid forecast with provenance per slot; provably optimal window search; real execution with a chained SHA-256 receipt; continuous re-planning; non-mutating preview; labelled time compression.</a:t>
             </a:r>
           </a:p>
           <a:p>
             <a:pPr algn="l" marL="539749" indent="-269875" lvl="1">
               <a:lnSpc>
-                <a:spcPts val="3499"/>
+                <a:spcPct val="100000"/>
               </a:lnSpc>
+              <a:spcBef>
+                <a:spcPts val="0"/>
+              </a:spcBef>
+              <a:spcAft>
+                <a:spcPts val="900"/>
+              </a:spcAft>
               <a:buFont typeface="Arial"/>
               <a:buChar char="•"/>
             </a:pPr>
@@ -5007,14 +5097,20 @@
                 <a:cs typeface="Aristotelica Pro"/>
                 <a:sym typeface="Aristotelica Pro"/>
               </a:rPr>
-              <a:t>Same work, same deadline, same output — up to 44% less CO₂, with no hardware change, no migration and no edit to the job itself. Deadlines are never missed: a job with no room to defer simply runs now.</a:t>
+              <a:t>Same work, same deadline, same output — up to 44% less CO₂, with no hardware change and no edit to the job. Deadlines are never missed: a job with no room to defer simply runs now.</a:t>
             </a:r>
           </a:p>
           <a:p>
             <a:pPr algn="l" marL="539749" indent="-269875" lvl="1">
               <a:lnSpc>
-                <a:spcPts val="3499"/>
+                <a:spcPct val="100000"/>
               </a:lnSpc>
+              <a:spcBef>
+                <a:spcPts val="0"/>
+              </a:spcBef>
+              <a:spcAft>
+                <a:spcPts val="900"/>
+              </a:spcAft>
               <a:buFont typeface="Arial"/>
               <a:buChar char="•"/>
             </a:pPr>
@@ -5060,26 +5156,26 @@
         </p:nvSpPr>
         <p:spPr>
           <a:xfrm rot="0">
-            <a:off x="3456097" y="3633417"/>
-            <a:ext cx="5261527" cy="1038225"/>
+            <a:off x="3456097" y="2240280"/>
+            <a:ext cx="10972800" cy="960120"/>
           </a:xfrm>
           <a:prstGeom prst="rect">
             <a:avLst/>
           </a:prstGeom>
         </p:spPr>
         <p:txBody>
-          <a:bodyPr anchor="t" rtlCol="false" tIns="0" lIns="0" bIns="0" rIns="0">
+          <a:bodyPr anchor="t" rtlCol="false" tIns="0" lIns="0" bIns="0" rIns="0" wrap="square">
             <a:spAutoFit/>
           </a:bodyPr>
           <a:lstStyle/>
           <a:p>
-            <a:pPr algn="ctr">
+            <a:pPr algn="l">
               <a:lnSpc>
                 <a:spcPts val="8400"/>
               </a:lnSpc>
             </a:pPr>
             <a:r>
-              <a:rPr lang="en-US" b="true" sz="6000">
+              <a:rPr lang="en-US" b="true" sz="5400">
                 <a:solidFill>
                   <a:srgbClr val="000000"/>
                 </a:solidFill>
@@ -5576,26 +5672,26 @@
         </p:nvSpPr>
         <p:spPr>
           <a:xfrm rot="0">
-            <a:off x="3045483" y="3639366"/>
-            <a:ext cx="6424550" cy="1038225"/>
+            <a:off x="3045483" y="2240280"/>
+            <a:ext cx="10972800" cy="960120"/>
           </a:xfrm>
           <a:prstGeom prst="rect">
             <a:avLst/>
           </a:prstGeom>
         </p:spPr>
         <p:txBody>
-          <a:bodyPr anchor="t" rtlCol="false" tIns="0" lIns="0" bIns="0" rIns="0">
+          <a:bodyPr anchor="t" rtlCol="false" tIns="0" lIns="0" bIns="0" rIns="0" wrap="square">
             <a:spAutoFit/>
           </a:bodyPr>
           <a:lstStyle/>
           <a:p>
-            <a:pPr algn="ctr">
+            <a:pPr algn="l">
               <a:lnSpc>
                 <a:spcPts val="8400"/>
               </a:lnSpc>
             </a:pPr>
             <a:r>
-              <a:rPr lang="en-US" b="true" sz="6000">
+              <a:rPr lang="en-US" b="true" sz="5400">
                 <a:solidFill>
                   <a:srgbClr val="000000"/>
                 </a:solidFill>
@@ -5755,8 +5851,8 @@
         </p:nvSpPr>
         <p:spPr>
           <a:xfrm rot="0">
-            <a:off x="2866717" y="4849041"/>
-            <a:ext cx="8641080" cy="4480560"/>
+            <a:off x="2866717" y="3346704"/>
+            <a:ext cx="8503920" cy="5541264"/>
           </a:xfrm>
           <a:prstGeom prst="rect">
             <a:avLst/>
@@ -5770,8 +5866,14 @@
           <a:p>
             <a:pPr algn="l" marL="539749" indent="-269875" lvl="1">
               <a:lnSpc>
-                <a:spcPts val="3499"/>
+                <a:spcPct val="100000"/>
               </a:lnSpc>
+              <a:spcBef>
+                <a:spcPts val="0"/>
+              </a:spcBef>
+              <a:spcAft>
+                <a:spcPts val="900"/>
+              </a:spcAft>
               <a:buFont typeface="Arial"/>
               <a:buChar char="•"/>
             </a:pPr>
@@ -5797,14 +5899,20 @@
                 <a:cs typeface="Aristotelica Pro"/>
                 <a:sym typeface="Aristotelica Pro"/>
               </a:rPr>
-              <a:t>Entry — New workload: name, energy budget, duration, deadline. Interaction — Preview scores the job and shows the chosen window before anything is queued; the queue then lists every deferred job with its execution window and estimated reduction. Outcome — the job runs at the chosen time and produces a downloadable, independently verifiable receipt.</a:t>
+              <a:t>Entry — New workload: name, energy budget, duration, deadline. Interaction — Preview scores the job and shows the chosen window before anything is queued. Outcome — the job runs at that time and produces a verifiable receipt.</a:t>
             </a:r>
           </a:p>
           <a:p>
             <a:pPr algn="l" marL="539749" indent="-269875" lvl="1">
               <a:lnSpc>
-                <a:spcPts val="3499"/>
+                <a:spcPct val="100000"/>
               </a:lnSpc>
+              <a:spcBef>
+                <a:spcPts val="0"/>
+              </a:spcBef>
+              <a:spcAft>
+                <a:spcPts val="900"/>
+              </a:spcAft>
               <a:buFont typeface="Arial"/>
               <a:buChar char="•"/>
             </a:pPr>
@@ -5818,7 +5926,7 @@
                 <a:cs typeface="Aristotelica Pro"/>
                 <a:sym typeface="Aristotelica Pro"/>
               </a:rPr>
-              <a:t>Key actions and decision points.  </a:t>
+              <a:t>Key decision points.  </a:t>
             </a:r>
             <a:r>
               <a:rPr lang="en-US" sz="1600" b="0">
@@ -5830,14 +5938,20 @@
                 <a:cs typeface="Aristotelica Pro"/>
                 <a:sym typeface="Aristotelica Pro"/>
               </a:rPr>
-              <a:t>Preview versus submit; accept the RUN or WAIT decision; cancel a deferred job; change clock speed to replay a full day of grid conditions. The engine re-decides every tick, so a queued job moves if the forecast improves.</a:t>
+              <a:t>Preview versus submit; accept the RUN or WAIT decision; cancel a deferred job; change clock speed to replay a full day. The engine re-decides every tick, so a queued job moves if the forecast improves.</a:t>
             </a:r>
           </a:p>
           <a:p>
             <a:pPr algn="l" marL="539749" indent="-269875" lvl="1">
               <a:lnSpc>
-                <a:spcPts val="3499"/>
+                <a:spcPct val="100000"/>
               </a:lnSpc>
+              <a:spcBef>
+                <a:spcPts val="0"/>
+              </a:spcBef>
+              <a:spcAft>
+                <a:spcPts val="900"/>
+              </a:spcAft>
               <a:buFont typeface="Arial"/>
               <a:buChar char="•"/>
             </a:pPr>
@@ -5863,14 +5977,20 @@
                 <a:cs typeface="Aristotelica Pro"/>
                 <a:sym typeface="Aristotelica Pro"/>
               </a:rPr>
-              <a:t>Every figure carries its provenance — real, derived or modelled — on screen rather than in a footnote. Every decision ships a plain-English reason. Preview never mutates the queue. Time compression is labelled at all times and never speeds up the workload itself. ARIA labels throughout, and CI fails the build on any mobile overflow or JavaScript runtime error.</a:t>
+              <a:t>Every figure carries its provenance — real, derived or modelled — on screen. Every decision ships a plain-English reason. Preview never mutates the queue. Time compression is labelled at all times and never speeds up the workload itself. ARIA labels throughout; CI fails on any mobile overflow or runtime error.</a:t>
             </a:r>
           </a:p>
           <a:p>
             <a:pPr algn="l" marL="539749" indent="-269875" lvl="1">
               <a:lnSpc>
-                <a:spcPts val="3499"/>
+                <a:spcPct val="100000"/>
               </a:lnSpc>
+              <a:spcBef>
+                <a:spcPts val="0"/>
+              </a:spcBef>
+              <a:spcAft>
+                <a:spcPts val="900"/>
+              </a:spcAft>
               <a:buFont typeface="Arial"/>
               <a:buChar char="•"/>
             </a:pPr>
@@ -5884,7 +6004,7 @@
                 <a:cs typeface="Aristotelica Pro"/>
                 <a:sym typeface="Aristotelica Pro"/>
               </a:rPr>
-              <a:t>Screenshots.  </a:t>
+              <a:t>Screenshot.  </a:t>
             </a:r>
             <a:r>
               <a:rPr lang="en-US" sz="1600" b="0">
@@ -5896,7 +6016,7 @@
                 <a:cs typeface="Aristotelica Pro"/>
                 <a:sym typeface="Aristotelica Pro"/>
               </a:rPr>
-              <a:t>Taken from the running application — the workload queue, with four deferred jobs and their chosen windows.</a:t>
+              <a:t>The live workload queue — four deferred jobs with their chosen execution windows and estimated reductions.</a:t>
             </a:r>
           </a:p>
           <a:p>
@@ -5924,7 +6044,7 @@
         </p:blipFill>
         <p:spPr>
           <a:xfrm>
-            <a:off x="12070080" y="4297680"/>
+            <a:off x="12070080" y="3346704"/>
             <a:ext cx="5349240" cy="3913632"/>
           </a:xfrm>
           <a:prstGeom prst="rect">
@@ -6277,8 +6397,8 @@
         </p:nvSpPr>
         <p:spPr>
           <a:xfrm rot="0">
-            <a:off x="3250176" y="4106667"/>
-            <a:ext cx="8778240" cy="4846320"/>
+            <a:off x="3250176" y="3346704"/>
+            <a:ext cx="8503920" cy="5541264"/>
           </a:xfrm>
           <a:prstGeom prst="rect">
             <a:avLst/>
@@ -6299,13 +6419,19 @@
           <a:p>
             <a:pPr algn="l" marL="539749" indent="-269875" lvl="1">
               <a:lnSpc>
-                <a:spcPts val="3499"/>
+                <a:spcPct val="100000"/>
               </a:lnSpc>
+              <a:spcBef>
+                <a:spcPts val="0"/>
+              </a:spcBef>
+              <a:spcAft>
+                <a:spcPts val="900"/>
+              </a:spcAft>
               <a:buFont typeface="Arial"/>
               <a:buChar char="•"/>
             </a:pPr>
             <a:r>
-              <a:rPr lang="en-US" sz="1600" b="1">
+              <a:rPr lang="en-US" sz="1550" b="1">
                 <a:solidFill>
                   <a:srgbClr val="000000"/>
                 </a:solidFill>
@@ -6314,10 +6440,10 @@
                 <a:cs typeface="Aristotelica Pro"/>
                 <a:sym typeface="Aristotelica Pro"/>
               </a:rPr>
-              <a:t>How the components communicate.  </a:t>
-            </a:r>
-            <a:r>
-              <a:rPr lang="en-US" sz="1600" b="0">
+              <a:t>Components.  </a:t>
+            </a:r>
+            <a:r>
+              <a:rPr lang="en-US" sz="1550" b="0">
                 <a:solidFill>
                   <a:srgbClr val="000000"/>
                 </a:solidFill>
@@ -6326,19 +6452,25 @@
                 <a:cs typeface="Aristotelica Pro"/>
                 <a:sym typeface="Aristotelica Pro"/>
               </a:rPr>
-              <a:t>The React control room polls the FastAPI backend every 1.5 seconds. FastAPI validates the job and calls the decision engine, which scores every candidate window against the cached forecast and returns RUN or WAIT. APScheduler holds the job and fires it at the chosen moment; the executor burns real CPU and writes a hash receipt. State is checkpointed to disk, so a restart does not lose the queue.</a:t>
+              <a:t>The React control room polls the FastAPI backend every 1.5s. FastAPI validates the job and calls the decision engine, which scores every candidate window and returns RUN or WAIT. APScheduler fires the job at the chosen moment; the executor burns real CPU and writes a hash receipt. State is checkpointed to disk.</a:t>
             </a:r>
           </a:p>
           <a:p>
             <a:pPr algn="l" marL="539749" indent="-269875" lvl="1">
               <a:lnSpc>
-                <a:spcPts val="3499"/>
+                <a:spcPct val="100000"/>
               </a:lnSpc>
+              <a:spcBef>
+                <a:spcPts val="0"/>
+              </a:spcBef>
+              <a:spcAft>
+                <a:spcPts val="900"/>
+              </a:spcAft>
               <a:buFont typeface="Arial"/>
               <a:buChar char="•"/>
             </a:pPr>
             <a:r>
-              <a:rPr lang="en-US" sz="1600" b="1">
+              <a:rPr lang="en-US" sz="1550" b="1">
                 <a:solidFill>
                   <a:srgbClr val="000000"/>
                 </a:solidFill>
@@ -6347,10 +6479,10 @@
                 <a:cs typeface="Aristotelica Pro"/>
                 <a:sym typeface="Aristotelica Pro"/>
               </a:rPr>
-              <a:t>Technical workflow.  </a:t>
-            </a:r>
-            <a:r>
-              <a:rPr lang="en-US" sz="1600" b="0">
+              <a:t>Workflow.  </a:t>
+            </a:r>
+            <a:r>
+              <a:rPr lang="en-US" sz="1550" b="0">
                 <a:solidFill>
                   <a:srgbClr val="000000"/>
                 </a:solidFill>
@@ -6365,13 +6497,19 @@
           <a:p>
             <a:pPr algn="l" marL="539749" indent="-269875" lvl="1">
               <a:lnSpc>
-                <a:spcPts val="3499"/>
+                <a:spcPct val="100000"/>
               </a:lnSpc>
+              <a:spcBef>
+                <a:spcPts val="0"/>
+              </a:spcBef>
+              <a:spcAft>
+                <a:spcPts val="900"/>
+              </a:spcAft>
               <a:buFont typeface="Arial"/>
               <a:buChar char="•"/>
             </a:pPr>
             <a:r>
-              <a:rPr lang="en-US" sz="1600" b="1">
+              <a:rPr lang="en-US" sz="1550" b="1">
                 <a:solidFill>
                   <a:srgbClr val="000000"/>
                 </a:solidFill>
@@ -6383,7 +6521,7 @@
               <a:t>Tech stack.  </a:t>
             </a:r>
             <a:r>
-              <a:rPr lang="en-US" sz="1600" b="0">
+              <a:rPr lang="en-US" sz="1550" b="0">
                 <a:solidFill>
                   <a:srgbClr val="000000"/>
                 </a:solidFill>
@@ -6398,13 +6536,19 @@
           <a:p>
             <a:pPr algn="l" marL="539749" indent="-269875" lvl="1">
               <a:lnSpc>
-                <a:spcPts val="3499"/>
+                <a:spcPct val="100000"/>
               </a:lnSpc>
+              <a:spcBef>
+                <a:spcPts val="0"/>
+              </a:spcBef>
+              <a:spcAft>
+                <a:spcPts val="900"/>
+              </a:spcAft>
               <a:buFont typeface="Arial"/>
               <a:buChar char="•"/>
             </a:pPr>
             <a:r>
-              <a:rPr lang="en-US" sz="1600" b="1">
+              <a:rPr lang="en-US" sz="1550" b="1">
                 <a:solidFill>
                   <a:srgbClr val="000000"/>
                 </a:solidFill>
@@ -6416,7 +6560,7 @@
               <a:t>External services.  </a:t>
             </a:r>
             <a:r>
-              <a:rPr lang="en-US" sz="1600" b="0">
+              <a:rPr lang="en-US" sz="1550" b="0">
                 <a:solidFill>
                   <a:srgbClr val="000000"/>
                 </a:solidFill>
@@ -6425,19 +6569,25 @@
                 <a:cs typeface="Aristotelica Pro"/>
                 <a:sym typeface="Aristotelica Pro"/>
               </a:rPr>
-              <a:t>UK National Grid Carbon Intensity API — GET /intensity/fw24h, 48 half-hour forecast slots, no API key required. Cached, with a synthetic fallback curve so a demo survives without internet. No AI models and no paid third-party services.</a:t>
+              <a:t>UK National Grid Carbon Intensity API — GET /intensity/fw24h, 48 half-hour slots, no API key. Cached, with a fallback curve so a demo survives without internet. No AI models, no paid services.</a:t>
             </a:r>
           </a:p>
           <a:p>
             <a:pPr algn="l" marL="539749" indent="-269875" lvl="1">
               <a:lnSpc>
-                <a:spcPts val="3499"/>
+                <a:spcPct val="100000"/>
               </a:lnSpc>
+              <a:spcBef>
+                <a:spcPts val="0"/>
+              </a:spcBef>
+              <a:spcAft>
+                <a:spcPts val="900"/>
+              </a:spcAft>
               <a:buFont typeface="Arial"/>
               <a:buChar char="•"/>
             </a:pPr>
             <a:r>
-              <a:rPr lang="en-US" sz="1600" b="1">
+              <a:rPr lang="en-US" sz="1550" b="1">
                 <a:solidFill>
                   <a:srgbClr val="000000"/>
                 </a:solidFill>
@@ -6449,7 +6599,7 @@
               <a:t>Key technical choices.  </a:t>
             </a:r>
             <a:r>
-              <a:rPr lang="en-US" sz="1600" b="0">
+              <a:rPr lang="en-US" sz="1550" b="0">
                 <a:solidFill>
                   <a:srgbClr val="000000"/>
                 </a:solidFill>
@@ -6458,19 +6608,25 @@
                 <a:cs typeface="Aristotelica Pro"/>
                 <a:sym typeface="Aristotelica Pro"/>
               </a:rPr>
-              <a:t>Breakpoint enumeration instead of sampling, because it is provably optimal and still instant. Fractional-slot energy weighting, so a 45-minute job is not charged two full half-hours. A virtual clock with re-anchoring, so compressed time never jumps. A real workload with a chained SHA-256 receipt, so execution is verifiable rather than simulated.</a:t>
+              <a:t>Breakpoint enumeration instead of sampling — provably optimal and still instant. Fractional-slot energy weighting, so a 45-minute job is not charged two full half-hours. A virtual clock with re-anchoring, so compressed time never jumps. A real workload with a hash receipt, so execution is verifiable.</a:t>
             </a:r>
           </a:p>
           <a:p>
             <a:pPr algn="l" marL="539749" indent="-269875" lvl="1">
               <a:lnSpc>
-                <a:spcPts val="3499"/>
+                <a:spcPct val="100000"/>
               </a:lnSpc>
+              <a:spcBef>
+                <a:spcPts val="0"/>
+              </a:spcBef>
+              <a:spcAft>
+                <a:spcPts val="900"/>
+              </a:spcAft>
               <a:buFont typeface="Arial"/>
               <a:buChar char="•"/>
             </a:pPr>
             <a:r>
-              <a:rPr lang="en-US" sz="1600" b="1">
+              <a:rPr lang="en-US" sz="1550" b="1">
                 <a:solidFill>
                   <a:srgbClr val="000000"/>
                 </a:solidFill>
@@ -6482,7 +6638,7 @@
               <a:t>GitHub.  </a:t>
             </a:r>
             <a:r>
-              <a:rPr lang="en-US" sz="1600" b="0">
+              <a:rPr lang="en-US" sz="1550" b="0">
                 <a:solidFill>
                   <a:srgbClr val="000000"/>
                 </a:solidFill>
@@ -6491,7 +6647,7 @@
                 <a:cs typeface="Aristotelica Pro"/>
                 <a:sym typeface="Aristotelica Pro"/>
               </a:rPr>
-              <a:t>github.com/krishiyswim23-swagger/ECO---ARB  —  29 backend tests, end-to-end Playwright smoke, CI green.</a:t>
+              <a:t>github.com/krishiyswim23-swagger/ECO---ARB — 29 backend tests, Playwright smoke, CI green.</a:t>
             </a:r>
           </a:p>
         </p:txBody>
@@ -6504,26 +6660,26 @@
         </p:nvSpPr>
         <p:spPr>
           <a:xfrm rot="0">
-            <a:off x="3566325" y="3573267"/>
-            <a:ext cx="5577675" cy="1038225"/>
+            <a:off x="3566325" y="2240280"/>
+            <a:ext cx="10972800" cy="960120"/>
           </a:xfrm>
           <a:prstGeom prst="rect">
             <a:avLst/>
           </a:prstGeom>
         </p:spPr>
         <p:txBody>
-          <a:bodyPr anchor="t" rtlCol="false" tIns="0" lIns="0" bIns="0" rIns="0">
+          <a:bodyPr anchor="t" rtlCol="false" tIns="0" lIns="0" bIns="0" rIns="0" wrap="square">
             <a:spAutoFit/>
           </a:bodyPr>
           <a:lstStyle/>
           <a:p>
-            <a:pPr algn="ctr">
+            <a:pPr algn="l">
               <a:lnSpc>
                 <a:spcPts val="8400"/>
               </a:lnSpc>
             </a:pPr>
             <a:r>
-              <a:rPr lang="en-US" b="true" sz="6000">
+              <a:rPr lang="en-US" b="true" sz="5400">
                 <a:solidFill>
                   <a:srgbClr val="000000"/>
                 </a:solidFill>
@@ -6691,8 +6847,8 @@
         </p:blipFill>
         <p:spPr>
           <a:xfrm>
-            <a:off x="12390120" y="4754880"/>
-            <a:ext cx="5074920" cy="1271016"/>
+            <a:off x="12161520" y="3346704"/>
+            <a:ext cx="5257800" cy="1316736"/>
           </a:xfrm>
           <a:prstGeom prst="rect">
             <a:avLst/>
@@ -6715,8 +6871,8 @@
         </p:blipFill>
         <p:spPr>
           <a:xfrm>
-            <a:off x="12390120" y="6263640"/>
-            <a:ext cx="2377440" cy="2514600"/>
+            <a:off x="12161520" y="4892040"/>
+            <a:ext cx="2487168" cy="2633472"/>
           </a:xfrm>
           <a:prstGeom prst="rect">
             <a:avLst/>
@@ -7068,8 +7224,8 @@
         </p:nvSpPr>
         <p:spPr>
           <a:xfrm rot="0">
-            <a:off x="3041177" y="5075006"/>
-            <a:ext cx="13560552" cy="4297680"/>
+            <a:off x="3041177" y="3346704"/>
+            <a:ext cx="13560552" cy="5541264"/>
           </a:xfrm>
           <a:prstGeom prst="rect">
             <a:avLst/>
@@ -7083,8 +7239,14 @@
           <a:p>
             <a:pPr algn="l" marL="539749" indent="-269875" lvl="1">
               <a:lnSpc>
-                <a:spcPts val="3499"/>
+                <a:spcPct val="100000"/>
               </a:lnSpc>
+              <a:spcBef>
+                <a:spcPts val="0"/>
+              </a:spcBef>
+              <a:spcAft>
+                <a:spcPts val="900"/>
+              </a:spcAft>
               <a:buFont typeface="Arial"/>
               <a:buChar char="•"/>
             </a:pPr>
@@ -7110,14 +7272,20 @@
                 <a:cs typeface="Aristotelica Pro"/>
                 <a:sym typeface="Aristotelica Pro"/>
               </a:rPr>
-              <a:t>Time-shifting rather than region-shifting, so it works on a single machine in a single region. And provable optimality: we enumerate every window that can be optimal and can show the proof, rather than sampling and hoping.</a:t>
+              <a:t>Time-shifting rather than region-shifting, so it works on a single machine in a single region — and provable optimality: we enumerate every window that can be optimal and can show the proof.</a:t>
             </a:r>
           </a:p>
           <a:p>
             <a:pPr algn="l" marL="539749" indent="-269875" lvl="1">
               <a:lnSpc>
-                <a:spcPts val="3499"/>
+                <a:spcPct val="100000"/>
               </a:lnSpc>
+              <a:spcBef>
+                <a:spcPts val="0"/>
+              </a:spcBef>
+              <a:spcAft>
+                <a:spcPts val="900"/>
+              </a:spcAft>
               <a:buFont typeface="Arial"/>
               <a:buChar char="•"/>
             </a:pPr>
@@ -7143,14 +7311,20 @@
                 <a:cs typeface="Aristotelica Pro"/>
                 <a:sym typeface="Aristotelica Pro"/>
               </a:rPr>
-              <a:t>Existing carbon tools measure and report; ECO-ARB acts. Region-shifting schedulers need multi-region infrastructure; we need none. And our figures are separated on screen into real, derived and modelled — most demos blur that line.</a:t>
+              <a:t>Existing carbon tools measure and report; ECO-ARB acts. Region-shifting schedulers need multi-region infrastructure; we need none. Our figures are separated on screen into real, derived and modelled.</a:t>
             </a:r>
           </a:p>
           <a:p>
             <a:pPr algn="l" marL="539749" indent="-269875" lvl="1">
               <a:lnSpc>
-                <a:spcPts val="3499"/>
+                <a:spcPct val="100000"/>
               </a:lnSpc>
+              <a:spcBef>
+                <a:spcPts val="0"/>
+              </a:spcBef>
+              <a:spcAft>
+                <a:spcPts val="900"/>
+              </a:spcAft>
               <a:buFont typeface="Arial"/>
               <a:buChar char="•"/>
             </a:pPr>
@@ -7176,14 +7350,20 @@
                 <a:cs typeface="Aristotelica Pro"/>
                 <a:sym typeface="Aristotelica Pro"/>
               </a:rPr>
-              <a:t>The same job, with the same deadline and the same output, emits 34–44% less CO₂ in our measured runs. Nothing about the workload or the hardware changes.</a:t>
+              <a:t>The same job, same deadline, same output — 34–44% less CO₂ in our measured runs. Nothing about the workload or the hardware changes.</a:t>
             </a:r>
           </a:p>
           <a:p>
             <a:pPr algn="l" marL="539749" indent="-269875" lvl="1">
               <a:lnSpc>
-                <a:spcPts val="3499"/>
+                <a:spcPct val="100000"/>
               </a:lnSpc>
+              <a:spcBef>
+                <a:spcPts val="0"/>
+              </a:spcBef>
+              <a:spcAft>
+                <a:spcPts val="900"/>
+              </a:spcAft>
               <a:buFont typeface="Arial"/>
               <a:buChar char="•"/>
             </a:pPr>
@@ -7209,14 +7389,20 @@
                 <a:cs typeface="Aristotelica Pro"/>
                 <a:sym typeface="Aristotelica Pro"/>
               </a:rPr>
-              <a:t>carbon_saved_pct and baseline versus optimal gCO₂ per job; cumulative kg CO₂ avoided; share of submitted jobs successfully deferred; deadline-miss rate, which is zero by construction.</a:t>
+              <a:t>carbon_saved_pct and baseline versus optimal gCO₂ per job; cumulative kg CO₂ avoided; share of jobs deferred; deadline-miss rate, zero by construction.</a:t>
             </a:r>
           </a:p>
           <a:p>
             <a:pPr algn="l" marL="539749" indent="-269875" lvl="1">
               <a:lnSpc>
-                <a:spcPts val="3499"/>
+                <a:spcPct val="100000"/>
               </a:lnSpc>
+              <a:spcBef>
+                <a:spcPts val="0"/>
+              </a:spcBef>
+              <a:spcAft>
+                <a:spcPts val="900"/>
+              </a:spcAft>
               <a:buFont typeface="Arial"/>
               <a:buChar char="•"/>
             </a:pPr>
@@ -7248,8 +7434,14 @@
           <a:p>
             <a:pPr algn="l" marL="539749" indent="-269875" lvl="1">
               <a:lnSpc>
-                <a:spcPts val="3499"/>
+                <a:spcPct val="100000"/>
               </a:lnSpc>
+              <a:spcBef>
+                <a:spcPts val="0"/>
+              </a:spcBef>
+              <a:spcAft>
+                <a:spcPts val="900"/>
+              </a:spcAft>
               <a:buFont typeface="Arial"/>
               <a:buChar char="•"/>
             </a:pPr>
@@ -7275,7 +7467,7 @@
                 <a:cs typeface="Aristotelica Pro"/>
                 <a:sym typeface="Aristotelica Pro"/>
               </a:rPr>
-              <a:t>A scheduling primitive: deadline, not start time. Proof it matters — our first engine only tried half-hour-aligned windows. On a 100 / 10 / 200 gCO₂ curve with a 45-minute job it ran immediately for 70 gCO₂, while the true optimum waited 15 minutes for 40 gCO₂. 43% left on the table. Found, fixed, and pinned with a regression test.</a:t>
+              <a:t>A scheduling primitive: deadline, not start time. Proof it matters — our first engine only tried half-hour-aligned windows. On a 100 / 10 / 200 gCO₂ curve with a 45-minute job it ran now for 70 gCO₂; the true optimum waited 15 minutes for 40 gCO₂. 43% left on the table. Found, fixed, regression-tested.</a:t>
             </a:r>
           </a:p>
         </p:txBody>
@@ -7288,26 +7480,26 @@
         </p:nvSpPr>
         <p:spPr>
           <a:xfrm rot="0">
-            <a:off x="3355284" y="3785281"/>
-            <a:ext cx="11577432" cy="1038225"/>
+            <a:off x="3355284" y="2240280"/>
+            <a:ext cx="15544800" cy="960120"/>
           </a:xfrm>
           <a:prstGeom prst="rect">
             <a:avLst/>
           </a:prstGeom>
         </p:spPr>
         <p:txBody>
-          <a:bodyPr anchor="t" rtlCol="false" tIns="0" lIns="0" bIns="0" rIns="0">
+          <a:bodyPr anchor="t" rtlCol="false" tIns="0" lIns="0" bIns="0" rIns="0" wrap="square">
             <a:spAutoFit/>
           </a:bodyPr>
           <a:lstStyle/>
           <a:p>
-            <a:pPr algn="ctr">
+            <a:pPr algn="l">
               <a:lnSpc>
                 <a:spcPts val="8400"/>
               </a:lnSpc>
             </a:pPr>
             <a:r>
-              <a:rPr lang="en-US" b="true" sz="6000">
+              <a:rPr lang="en-US" b="true" sz="4800">
                 <a:solidFill>
                   <a:srgbClr val="000000"/>
                 </a:solidFill>

</xml_diff>